<commit_message>
Docs: reconcile to single-author (solo) framing
Rewrite the guide/deck/demo-script from a mentor-to-team voice into a
solo build narrative: author line = Paing Hein Htet, drop the 4-member
deck placeholder and 'your team'/'4 presenters'/'our build' phrasing.
Rebuilt EMG_Hand_Presentation.pptx and START_HERE.pdf.
</commit_message>
<xml_diff>
--- a/EMG_Hand_Presentation.pptx
+++ b/EMG_Hand_Presentation.pptx
@@ -1712,7 +1712,7 @@
                 <a:ea typeface="Calibri" pitchFamily="34" charset="-122"/>
                 <a:cs typeface="Calibri" pitchFamily="34" charset="-120"/>
               </a:rPr>
-              <a:t>Team   </a:t>
+              <a:t>Author   </a:t>
             </a:r>
             <a:pPr algn="l" indent="0" marL="0">
               <a:buNone/>
@@ -1726,7 +1726,7 @@
                 <a:ea typeface="Calibri" pitchFamily="34" charset="-122"/>
                 <a:cs typeface="Calibri" pitchFamily="34" charset="-120"/>
               </a:rPr>
-              <a:t>[Member 1]    [Member 2]    [Member 3]    [Member 4]</a:t>
+              <a:t>Paing Hein Htet</a:t>
             </a:r>
             <a:endParaRPr lang="en-US" sz="1400" dirty="0"/>
           </a:p>

</xml_diff>